<commit_message>
Cheat-sheet PDF: mirror page 7 (donor-figure display + honest claim ladder)
Brings the PDF cheat-sheet in line with the HTML's page 2: figure-display choices
(dots + mean ± SEM, the error-bar menu, mean vs median) and the claim ladder
(never "intact"; no detectable signal; large shift excluded; subtle drift not).
Renumbered the reference pages to /7 and regenerated the PDF.

Co-Authored-By: Claude Opus 4.8 <noreply@anthropic.com>
</commit_message>
<xml_diff>
--- a/presentation/build/cheatsheet.pptx
+++ b/presentation/build/cheatsheet.pptx
@@ -11,9 +11,10 @@
     <p:sldId id="259" r:id="rId5"/>
     <p:sldId id="260" r:id="rId6"/>
     <p:sldId id="261" r:id="rId7"/>
+    <p:sldId id="262" r:id="rId8"/>
   </p:sldIdLst>
   <p:notesMasterIdLst>
-    <p:notesMasterId r:id="rId8"/>
+    <p:notesMasterId r:id="rId9"/>
   </p:notesMasterIdLst>
   <p:sldSz cx="12192000" cy="6858000"/>
   <p:notesSz cx="6858000" cy="12192000"/>
@@ -989,6 +990,94 @@
 </p:notes>
 </file>
 
+<file path=ppt/notesSlides/notesSlide7.xml><?xml version="1.0" encoding="utf-8"?>
+<p:notes xmlns:a="http://schemas.openxmlformats.org/drawingml/2006/main" xmlns:r="http://schemas.openxmlformats.org/officeDocument/2006/relationships" xmlns:p="http://schemas.openxmlformats.org/presentationml/2006/main">
+  <p:cSld>
+    <p:spTree>
+      <p:nvGrpSpPr>
+        <p:cNvPr id="1" name=""/>
+        <p:cNvGrpSpPr/>
+        <p:nvPr/>
+      </p:nvGrpSpPr>
+      <p:grpSpPr>
+        <a:xfrm>
+          <a:off x="0" y="0"/>
+          <a:ext cx="0" cy="0"/>
+          <a:chOff x="0" y="0"/>
+          <a:chExt cx="0" cy="0"/>
+        </a:xfrm>
+      </p:grpSpPr>
+      <p:sp>
+        <p:nvSpPr>
+          <p:cNvPr id="2" name="Slide Image Placeholder 1"/>
+          <p:cNvSpPr>
+            <a:spLocks noGrp="1" noRot="1" noChangeAspect="1"/>
+          </p:cNvSpPr>
+          <p:nvPr>
+            <p:ph type="sldImg"/>
+          </p:nvPr>
+        </p:nvSpPr>
+        <p:spPr/>
+      </p:sp>
+      <p:sp>
+        <p:nvSpPr>
+          <p:cNvPr id="3" name="Notes Placeholder 2"/>
+          <p:cNvSpPr>
+            <a:spLocks noGrp="1"/>
+          </p:cNvSpPr>
+          <p:nvPr>
+            <p:ph type="body" idx="1"/>
+          </p:nvPr>
+        </p:nvSpPr>
+        <p:spPr/>
+        <p:txBody>
+          <a:bodyPr/>
+          <a:lstStyle/>
+          <a:p>
+            <a:r>
+              <a:rPr lang="en-US" dirty="0"/>
+              <a:t/>
+            </a:r>
+            <a:endParaRPr lang="en-US" dirty="0"/>
+          </a:p>
+        </p:txBody>
+      </p:sp>
+      <p:sp>
+        <p:nvSpPr>
+          <p:cNvPr id="4" name="Slide Number Placeholder 3"/>
+          <p:cNvSpPr>
+            <a:spLocks noGrp="1"/>
+          </p:cNvSpPr>
+          <p:nvPr>
+            <p:ph type="sldNum" sz="quarter" idx="10"/>
+          </p:nvPr>
+        </p:nvSpPr>
+        <p:spPr/>
+        <p:txBody>
+          <a:bodyPr/>
+          <a:lstStyle/>
+          <a:p>
+            <a:fld id="{F7021451-1387-4CA6-816F-3879F97B5CBC}" type="slidenum">
+              <a:rPr lang="en-US"/>
+              <a:t>7</a:t>
+            </a:fld>
+            <a:endParaRPr lang="en-US"/>
+          </a:p>
+        </p:txBody>
+      </p:sp>
+    </p:spTree>
+    <p:extLst>
+      <p:ext uri="{BB962C8B-B14F-4D97-AF65-F5344CB8AC3E}">
+        <p14:creationId xmlns:p14="http://schemas.microsoft.com/office/powerpoint/2010/main" val="1024086991"/>
+      </p:ext>
+    </p:extLst>
+  </p:cSld>
+  <p:clrMapOvr>
+    <a:masterClrMapping/>
+  </p:clrMapOvr>
+</p:notes>
+</file>
+
 <file path=ppt/slideLayouts/slideLayout1.xml><?xml version="1.0" encoding="utf-8"?>
 <p:sldLayout xmlns:a="http://schemas.openxmlformats.org/drawingml/2006/main" xmlns:r="http://schemas.openxmlformats.org/officeDocument/2006/relationships" xmlns:p="http://schemas.openxmlformats.org/presentationml/2006/main" preserve="1">
   <p:cSld name="DEFAULT">
@@ -1390,7 +1479,7 @@
                   <a:srgbClr val="C0561B"/>
                 </a:solidFill>
               </a:rPr>
-              <a:t>REFERENCE · 1 / 6</a:t>
+              <a:t>REFERENCE · 1 / 7</a:t>
             </a:r>
             <a:endParaRPr lang="en-US" sz="1300" dirty="0"/>
           </a:p>
@@ -2595,7 +2684,7 @@
                   <a:srgbClr val="C0561B"/>
                 </a:solidFill>
               </a:rPr>
-              <a:t>REFERENCE · 2 / 6</a:t>
+              <a:t>REFERENCE · 2 / 7</a:t>
             </a:r>
             <a:endParaRPr lang="en-US" sz="1300" dirty="0"/>
           </a:p>
@@ -3800,7 +3889,7 @@
                   <a:srgbClr val="C0561B"/>
                 </a:solidFill>
               </a:rPr>
-              <a:t>REFERENCE · 3 / 6</a:t>
+              <a:t>REFERENCE · 3 / 7</a:t>
             </a:r>
             <a:endParaRPr lang="en-US" sz="1300" dirty="0"/>
           </a:p>
@@ -4881,7 +4970,7 @@
                   <a:srgbClr val="C0561B"/>
                 </a:solidFill>
               </a:rPr>
-              <a:t>REFERENCE · 4 / 6</a:t>
+              <a:t>REFERENCE · 4 / 7</a:t>
             </a:r>
             <a:endParaRPr lang="en-US" sz="1300" dirty="0"/>
           </a:p>
@@ -5714,7 +5803,7 @@
                   <a:srgbClr val="C0561B"/>
                 </a:solidFill>
               </a:rPr>
-              <a:t>REFERENCE · 5 / 6</a:t>
+              <a:t>REFERENCE · 5 / 7</a:t>
             </a:r>
             <a:endParaRPr lang="en-US" sz="1300" dirty="0"/>
           </a:p>
@@ -6547,7 +6636,7 @@
                   <a:srgbClr val="C0561B"/>
                 </a:solidFill>
               </a:rPr>
-              <a:t>REFERENCE · 6 / 6</a:t>
+              <a:t>REFERENCE · 6 / 7</a:t>
             </a:r>
             <a:endParaRPr lang="en-US" sz="1300" dirty="0"/>
           </a:p>
@@ -7563,6 +7652,1211 @@
                           </a:solidFill>
                         </a:rPr>
                         <a:t>TOST excludes shifts &gt; ±19 pp; a ≤ 10-pp drift stays possible — “no large change,” not “exactly zero.”</a:t>
+                      </a:r>
+                      <a:endParaRPr lang="en-US" sz="1150" dirty="0"/>
+                    </a:p>
+                  </a:txBody>
+                  <a:tcPr marL="76200" marR="76200" marT="38100" marB="38100" anchor="ctr">
+                    <a:lnL w="6350" cap="flat" cmpd="sng" algn="ctr">
+                      <a:solidFill>
+                        <a:srgbClr val="E2DCCF"/>
+                      </a:solidFill>
+                      <a:prstDash val="solid"/>
+                      <a:round/>
+                      <a:headEnd type="none" w="med" len="med"/>
+                      <a:tailEnd type="none" w="med" len="med"/>
+                    </a:lnL>
+                    <a:lnR w="6350" cap="flat" cmpd="sng" algn="ctr">
+                      <a:solidFill>
+                        <a:srgbClr val="E2DCCF"/>
+                      </a:solidFill>
+                      <a:prstDash val="solid"/>
+                      <a:round/>
+                      <a:headEnd type="none" w="med" len="med"/>
+                      <a:tailEnd type="none" w="med" len="med"/>
+                    </a:lnR>
+                    <a:lnT w="6350" cap="flat" cmpd="sng" algn="ctr">
+                      <a:solidFill>
+                        <a:srgbClr val="E2DCCF"/>
+                      </a:solidFill>
+                      <a:prstDash val="solid"/>
+                      <a:round/>
+                      <a:headEnd type="none" w="med" len="med"/>
+                      <a:tailEnd type="none" w="med" len="med"/>
+                    </a:lnT>
+                    <a:lnB w="6350" cap="flat" cmpd="sng" algn="ctr">
+                      <a:solidFill>
+                        <a:srgbClr val="E2DCCF"/>
+                      </a:solidFill>
+                      <a:prstDash val="solid"/>
+                      <a:round/>
+                      <a:headEnd type="none" w="med" len="med"/>
+                      <a:tailEnd type="none" w="med" len="med"/>
+                    </a:lnB>
+                    <a:solidFill>
+                      <a:srgbClr val="FFFFFF"/>
+                    </a:solidFill>
+                  </a:tcPr>
+                </a:tc>
+              </a:tr>
+            </a:tbl>
+          </a:graphicData>
+        </a:graphic>
+      </p:graphicFrame>
+      <p:sp>
+        <p:nvSpPr>
+          <p:cNvPr id="7" name="Text 4"/>
+          <p:cNvSpPr/>
+          <p:nvPr/>
+        </p:nvSpPr>
+        <p:spPr>
+          <a:xfrm>
+            <a:off x="457200" y="6510528"/>
+            <a:ext cx="11247120" cy="274320"/>
+          </a:xfrm>
+          <a:prstGeom prst="rect">
+            <a:avLst/>
+          </a:prstGeom>
+          <a:noFill/>
+          <a:ln/>
+        </p:spPr>
+        <p:txBody>
+          <a:bodyPr wrap="square" lIns="0" tIns="0" rIns="0" bIns="0" rtlCol="0" anchor="ctr"/>
+          <a:lstStyle/>
+          <a:p>
+            <a:pPr algn="l" indent="0" marL="0">
+              <a:buNone/>
+            </a:pPr>
+            <a:r>
+              <a:rPr lang="en-US" sz="1000" dirty="0">
+                <a:solidFill>
+                  <a:srgbClr val="5C6E73"/>
+                </a:solidFill>
+              </a:rPr>
+              <a:t>Computational Genomics 76553  ·  HUJI  ·  MASLD snRNA-seq hackathon  —  methods &amp; concepts reference</a:t>
+            </a:r>
+            <a:endParaRPr lang="en-US" sz="1000" dirty="0"/>
+          </a:p>
+        </p:txBody>
+      </p:sp>
+    </p:spTree>
+  </p:cSld>
+  <p:clrMapOvr>
+    <a:masterClrMapping/>
+  </p:clrMapOvr>
+</p:sld>
+</file>
+
+<file path=ppt/slides/slide7.xml><?xml version="1.0" encoding="utf-8"?>
+<p:sld xmlns:a="http://schemas.openxmlformats.org/drawingml/2006/main" xmlns:r="http://schemas.openxmlformats.org/officeDocument/2006/relationships" xmlns:p="http://schemas.openxmlformats.org/presentationml/2006/main">
+  <p:cSld name="Slide 7">
+    <p:bg>
+      <p:bgPr>
+        <a:solidFill>
+          <a:srgbClr val="F7F5F1"/>
+        </a:solidFill>
+      </p:bgPr>
+    </p:bg>
+    <p:spTree>
+      <p:nvGrpSpPr>
+        <p:cNvPr id="1" name=""/>
+        <p:cNvGrpSpPr/>
+        <p:nvPr/>
+      </p:nvGrpSpPr>
+      <p:grpSpPr>
+        <a:xfrm>
+          <a:off x="0" y="0"/>
+          <a:ext cx="0" cy="0"/>
+          <a:chOff x="0" y="0"/>
+          <a:chExt cx="0" cy="0"/>
+        </a:xfrm>
+      </p:grpSpPr>
+      <p:sp>
+        <p:nvSpPr>
+          <p:cNvPr id="2" name="Shape 0"/>
+          <p:cNvSpPr/>
+          <p:nvPr/>
+        </p:nvSpPr>
+        <p:spPr>
+          <a:xfrm>
+            <a:off x="0" y="0"/>
+            <a:ext cx="12191695" cy="6858000"/>
+          </a:xfrm>
+          <a:prstGeom prst="rect">
+            <a:avLst/>
+          </a:prstGeom>
+          <a:solidFill>
+            <a:srgbClr val="F7F5F1"/>
+          </a:solidFill>
+          <a:ln/>
+        </p:spPr>
+      </p:sp>
+      <p:sp>
+        <p:nvSpPr>
+          <p:cNvPr id="3" name="Shape 1"/>
+          <p:cNvSpPr/>
+          <p:nvPr/>
+        </p:nvSpPr>
+        <p:spPr>
+          <a:xfrm>
+            <a:off x="457200" y="310896"/>
+            <a:ext cx="146304" cy="237744"/>
+          </a:xfrm>
+          <a:prstGeom prst="rect">
+            <a:avLst/>
+          </a:prstGeom>
+          <a:solidFill>
+            <a:srgbClr val="C0561B"/>
+          </a:solidFill>
+          <a:ln/>
+        </p:spPr>
+      </p:sp>
+      <p:sp>
+        <p:nvSpPr>
+          <p:cNvPr id="4" name="Text 2"/>
+          <p:cNvSpPr/>
+          <p:nvPr/>
+        </p:nvSpPr>
+        <p:spPr>
+          <a:xfrm>
+            <a:off x="676656" y="274320"/>
+            <a:ext cx="10058400" cy="320040"/>
+          </a:xfrm>
+          <a:prstGeom prst="rect">
+            <a:avLst/>
+          </a:prstGeom>
+          <a:noFill/>
+          <a:ln/>
+        </p:spPr>
+        <p:txBody>
+          <a:bodyPr wrap="square" lIns="0" tIns="0" rIns="0" bIns="0" rtlCol="0" anchor="ctr"/>
+          <a:lstStyle/>
+          <a:p>
+            <a:pPr algn="l" indent="0" marL="0">
+              <a:buNone/>
+            </a:pPr>
+            <a:r>
+              <a:rPr lang="en-US" sz="1300" b="1" spc="300" kern="0" dirty="0">
+                <a:solidFill>
+                  <a:srgbClr val="C0561B"/>
+                </a:solidFill>
+              </a:rPr>
+              <a:t>REFERENCE · 7 / 7</a:t>
+            </a:r>
+            <a:endParaRPr lang="en-US" sz="1300" dirty="0"/>
+          </a:p>
+        </p:txBody>
+      </p:sp>
+      <p:sp>
+        <p:nvSpPr>
+          <p:cNvPr id="5" name="Text 3"/>
+          <p:cNvSpPr/>
+          <p:nvPr/>
+        </p:nvSpPr>
+        <p:spPr>
+          <a:xfrm>
+            <a:off x="438912" y="585216"/>
+            <a:ext cx="11338560" cy="640080"/>
+          </a:xfrm>
+          <a:prstGeom prst="rect">
+            <a:avLst/>
+          </a:prstGeom>
+          <a:noFill/>
+          <a:ln/>
+        </p:spPr>
+        <p:txBody>
+          <a:bodyPr wrap="square" lIns="0" tIns="0" rIns="0" bIns="0" rtlCol="0" anchor="t"/>
+          <a:lstStyle/>
+          <a:p>
+            <a:pPr algn="l" indent="0" marL="0">
+              <a:buNone/>
+            </a:pPr>
+            <a:r>
+              <a:rPr lang="en-US" sz="2600" b="1" dirty="0">
+                <a:solidFill>
+                  <a:srgbClr val="1B2B31"/>
+                </a:solidFill>
+                <a:latin typeface="Georgia" pitchFamily="34" charset="0"/>
+                <a:ea typeface="Georgia" pitchFamily="34" charset="-122"/>
+                <a:cs typeface="Georgia" pitchFamily="34" charset="-120"/>
+              </a:rPr>
+              <a:t>Donor figures: display &amp; honest claims</a:t>
+            </a:r>
+            <a:endParaRPr lang="en-US" sz="2600" dirty="0"/>
+          </a:p>
+        </p:txBody>
+      </p:sp>
+      <p:graphicFrame>
+        <p:nvGraphicFramePr>
+          <p:cNvPr id="8" name="Table 0"/>
+          <p:cNvGraphicFramePr>
+            <a:graphicFrameLocks noGrp="1"/>
+          </p:cNvGraphicFramePr>
+          <p:nvPr>
+            <p:extLst>
+              <p:ext uri="{D42A27DB-BD31-4B8C-83A1-F6EECF244321}">
+                <p14:modId xmlns:p14="http://schemas.microsoft.com/office/powerpoint/2010/main" val="1579011935"/>
+              </p:ext>
+            </p:extLst>
+          </p:nvPr>
+        </p:nvGraphicFramePr>
+        <p:xfrm>
+          <a:off x="457200" y="1371600"/>
+          <a:ext cx="11274552" cy="914400"/>
+        </p:xfrm>
+        <a:graphic>
+          <a:graphicData uri="http://schemas.openxmlformats.org/drawingml/2006/table">
+            <a:tbl>
+              <a:tblPr/>
+              <a:tblGrid>
+                <a:gridCol w="2697480"/>
+                <a:gridCol w="8577072"/>
+              </a:tblGrid>
+              <a:tr h="274320">
+                <a:tc>
+                  <a:txBody>
+                    <a:bodyPr/>
+                    <a:lstStyle/>
+                    <a:p>
+                      <a:pPr algn="l" indent="0" marL="0">
+                        <a:buNone/>
+                      </a:pPr>
+                      <a:r>
+                        <a:rPr lang="en-US" sz="1150" b="1" dirty="0">
+                          <a:solidFill>
+                            <a:srgbClr val="1B6E78"/>
+                          </a:solidFill>
+                        </a:rPr>
+                        <a:t>What the bar shows</a:t>
+                      </a:r>
+                      <a:endParaRPr lang="en-US" sz="1150" dirty="0"/>
+                    </a:p>
+                  </a:txBody>
+                  <a:tcPr marL="76200" marR="76200" marT="38100" marB="38100" anchor="ctr">
+                    <a:lnL w="6350" cap="flat" cmpd="sng" algn="ctr">
+                      <a:solidFill>
+                        <a:srgbClr val="E2DCCF"/>
+                      </a:solidFill>
+                      <a:prstDash val="solid"/>
+                      <a:round/>
+                      <a:headEnd type="none" w="med" len="med"/>
+                      <a:tailEnd type="none" w="med" len="med"/>
+                    </a:lnL>
+                    <a:lnR w="6350" cap="flat" cmpd="sng" algn="ctr">
+                      <a:solidFill>
+                        <a:srgbClr val="E2DCCF"/>
+                      </a:solidFill>
+                      <a:prstDash val="solid"/>
+                      <a:round/>
+                      <a:headEnd type="none" w="med" len="med"/>
+                      <a:tailEnd type="none" w="med" len="med"/>
+                    </a:lnR>
+                    <a:lnT w="6350" cap="flat" cmpd="sng" algn="ctr">
+                      <a:solidFill>
+                        <a:srgbClr val="E2DCCF"/>
+                      </a:solidFill>
+                      <a:prstDash val="solid"/>
+                      <a:round/>
+                      <a:headEnd type="none" w="med" len="med"/>
+                      <a:tailEnd type="none" w="med" len="med"/>
+                    </a:lnT>
+                    <a:lnB w="6350" cap="flat" cmpd="sng" algn="ctr">
+                      <a:solidFill>
+                        <a:srgbClr val="E2DCCF"/>
+                      </a:solidFill>
+                      <a:prstDash val="solid"/>
+                      <a:round/>
+                      <a:headEnd type="none" w="med" len="med"/>
+                      <a:tailEnd type="none" w="med" len="med"/>
+                    </a:lnB>
+                    <a:solidFill>
+                      <a:srgbClr val="FFFFFF"/>
+                    </a:solidFill>
+                  </a:tcPr>
+                </a:tc>
+                <a:tc>
+                  <a:txBody>
+                    <a:bodyPr/>
+                    <a:lstStyle/>
+                    <a:p>
+                      <a:pPr algn="l" indent="0" marL="0">
+                        <a:buNone/>
+                      </a:pPr>
+                      <a:r>
+                        <a:rPr lang="en-US" sz="1150" dirty="0">
+                          <a:solidFill>
+                            <a:srgbClr val="1B2B31"/>
+                          </a:solidFill>
+                        </a:rPr>
+                        <a:t>Dots = every donor (the spread + outliers — nothing hidden). The error bar shows the precision of the center — NOT the spread again (the dots already show that).</a:t>
+                      </a:r>
+                      <a:endParaRPr lang="en-US" sz="1150" dirty="0"/>
+                    </a:p>
+                  </a:txBody>
+                  <a:tcPr marL="76200" marR="76200" marT="38100" marB="38100" anchor="ctr">
+                    <a:lnL w="6350" cap="flat" cmpd="sng" algn="ctr">
+                      <a:solidFill>
+                        <a:srgbClr val="E2DCCF"/>
+                      </a:solidFill>
+                      <a:prstDash val="solid"/>
+                      <a:round/>
+                      <a:headEnd type="none" w="med" len="med"/>
+                      <a:tailEnd type="none" w="med" len="med"/>
+                    </a:lnL>
+                    <a:lnR w="6350" cap="flat" cmpd="sng" algn="ctr">
+                      <a:solidFill>
+                        <a:srgbClr val="E2DCCF"/>
+                      </a:solidFill>
+                      <a:prstDash val="solid"/>
+                      <a:round/>
+                      <a:headEnd type="none" w="med" len="med"/>
+                      <a:tailEnd type="none" w="med" len="med"/>
+                    </a:lnR>
+                    <a:lnT w="6350" cap="flat" cmpd="sng" algn="ctr">
+                      <a:solidFill>
+                        <a:srgbClr val="E2DCCF"/>
+                      </a:solidFill>
+                      <a:prstDash val="solid"/>
+                      <a:round/>
+                      <a:headEnd type="none" w="med" len="med"/>
+                      <a:tailEnd type="none" w="med" len="med"/>
+                    </a:lnT>
+                    <a:lnB w="6350" cap="flat" cmpd="sng" algn="ctr">
+                      <a:solidFill>
+                        <a:srgbClr val="E2DCCF"/>
+                      </a:solidFill>
+                      <a:prstDash val="solid"/>
+                      <a:round/>
+                      <a:headEnd type="none" w="med" len="med"/>
+                      <a:tailEnd type="none" w="med" len="med"/>
+                    </a:lnB>
+                    <a:solidFill>
+                      <a:srgbClr val="FFFFFF"/>
+                    </a:solidFill>
+                  </a:tcPr>
+                </a:tc>
+              </a:tr>
+              <a:tr h="274320">
+                <a:tc>
+                  <a:txBody>
+                    <a:bodyPr/>
+                    <a:lstStyle/>
+                    <a:p>
+                      <a:pPr algn="l" indent="0" marL="0">
+                        <a:buNone/>
+                      </a:pPr>
+                      <a:r>
+                        <a:rPr lang="en-US" sz="1150" b="1" dirty="0">
+                          <a:solidFill>
+                            <a:srgbClr val="1B6E78"/>
+                          </a:solidFill>
+                        </a:rPr>
+                        <a:t>SD / IQR / whiskers</a:t>
+                      </a:r>
+                      <a:endParaRPr lang="en-US" sz="1150" dirty="0"/>
+                    </a:p>
+                  </a:txBody>
+                  <a:tcPr marL="76200" marR="76200" marT="38100" marB="38100" anchor="ctr">
+                    <a:lnL w="6350" cap="flat" cmpd="sng" algn="ctr">
+                      <a:solidFill>
+                        <a:srgbClr val="E2DCCF"/>
+                      </a:solidFill>
+                      <a:prstDash val="solid"/>
+                      <a:round/>
+                      <a:headEnd type="none" w="med" len="med"/>
+                      <a:tailEnd type="none" w="med" len="med"/>
+                    </a:lnL>
+                    <a:lnR w="6350" cap="flat" cmpd="sng" algn="ctr">
+                      <a:solidFill>
+                        <a:srgbClr val="E2DCCF"/>
+                      </a:solidFill>
+                      <a:prstDash val="solid"/>
+                      <a:round/>
+                      <a:headEnd type="none" w="med" len="med"/>
+                      <a:tailEnd type="none" w="med" len="med"/>
+                    </a:lnR>
+                    <a:lnT w="6350" cap="flat" cmpd="sng" algn="ctr">
+                      <a:solidFill>
+                        <a:srgbClr val="E2DCCF"/>
+                      </a:solidFill>
+                      <a:prstDash val="solid"/>
+                      <a:round/>
+                      <a:headEnd type="none" w="med" len="med"/>
+                      <a:tailEnd type="none" w="med" len="med"/>
+                    </a:lnT>
+                    <a:lnB w="6350" cap="flat" cmpd="sng" algn="ctr">
+                      <a:solidFill>
+                        <a:srgbClr val="E2DCCF"/>
+                      </a:solidFill>
+                      <a:prstDash val="solid"/>
+                      <a:round/>
+                      <a:headEnd type="none" w="med" len="med"/>
+                      <a:tailEnd type="none" w="med" len="med"/>
+                    </a:lnB>
+                    <a:solidFill>
+                      <a:srgbClr val="FFFFFF"/>
+                    </a:solidFill>
+                  </a:tcPr>
+                </a:tc>
+                <a:tc>
+                  <a:txBody>
+                    <a:bodyPr/>
+                    <a:lstStyle/>
+                    <a:p>
+                      <a:pPr algn="l" indent="0" marL="0">
+                        <a:buNone/>
+                      </a:pPr>
+                      <a:r>
+                        <a:rPr lang="en-US" sz="1150" dirty="0">
+                          <a:solidFill>
+                            <a:srgbClr val="1B2B31"/>
+                          </a:solidFill>
+                        </a:rPr>
+                        <a:t>Spread of donors (descriptive); redundant with the dots — and median + IQR is literally the box plot's box.</a:t>
+                      </a:r>
+                      <a:endParaRPr lang="en-US" sz="1150" dirty="0"/>
+                    </a:p>
+                  </a:txBody>
+                  <a:tcPr marL="76200" marR="76200" marT="38100" marB="38100" anchor="ctr">
+                    <a:lnL w="6350" cap="flat" cmpd="sng" algn="ctr">
+                      <a:solidFill>
+                        <a:srgbClr val="E2DCCF"/>
+                      </a:solidFill>
+                      <a:prstDash val="solid"/>
+                      <a:round/>
+                      <a:headEnd type="none" w="med" len="med"/>
+                      <a:tailEnd type="none" w="med" len="med"/>
+                    </a:lnL>
+                    <a:lnR w="6350" cap="flat" cmpd="sng" algn="ctr">
+                      <a:solidFill>
+                        <a:srgbClr val="E2DCCF"/>
+                      </a:solidFill>
+                      <a:prstDash val="solid"/>
+                      <a:round/>
+                      <a:headEnd type="none" w="med" len="med"/>
+                      <a:tailEnd type="none" w="med" len="med"/>
+                    </a:lnR>
+                    <a:lnT w="6350" cap="flat" cmpd="sng" algn="ctr">
+                      <a:solidFill>
+                        <a:srgbClr val="E2DCCF"/>
+                      </a:solidFill>
+                      <a:prstDash val="solid"/>
+                      <a:round/>
+                      <a:headEnd type="none" w="med" len="med"/>
+                      <a:tailEnd type="none" w="med" len="med"/>
+                    </a:lnT>
+                    <a:lnB w="6350" cap="flat" cmpd="sng" algn="ctr">
+                      <a:solidFill>
+                        <a:srgbClr val="E2DCCF"/>
+                      </a:solidFill>
+                      <a:prstDash val="solid"/>
+                      <a:round/>
+                      <a:headEnd type="none" w="med" len="med"/>
+                      <a:tailEnd type="none" w="med" len="med"/>
+                    </a:lnB>
+                    <a:solidFill>
+                      <a:srgbClr val="FFFFFF"/>
+                    </a:solidFill>
+                  </a:tcPr>
+                </a:tc>
+              </a:tr>
+              <a:tr h="274320">
+                <a:tc>
+                  <a:txBody>
+                    <a:bodyPr/>
+                    <a:lstStyle/>
+                    <a:p>
+                      <a:pPr algn="l" indent="0" marL="0">
+                        <a:buNone/>
+                      </a:pPr>
+                      <a:r>
+                        <a:rPr lang="en-US" sz="1150" b="1" dirty="0">
+                          <a:solidFill>
+                            <a:srgbClr val="1B6E78"/>
+                          </a:solidFill>
+                        </a:rPr>
+                        <a:t>SEM = SD/√n</a:t>
+                      </a:r>
+                      <a:endParaRPr lang="en-US" sz="1150" dirty="0"/>
+                    </a:p>
+                  </a:txBody>
+                  <a:tcPr marL="76200" marR="76200" marT="38100" marB="38100" anchor="ctr">
+                    <a:lnL w="6350" cap="flat" cmpd="sng" algn="ctr">
+                      <a:solidFill>
+                        <a:srgbClr val="E2DCCF"/>
+                      </a:solidFill>
+                      <a:prstDash val="solid"/>
+                      <a:round/>
+                      <a:headEnd type="none" w="med" len="med"/>
+                      <a:tailEnd type="none" w="med" len="med"/>
+                    </a:lnL>
+                    <a:lnR w="6350" cap="flat" cmpd="sng" algn="ctr">
+                      <a:solidFill>
+                        <a:srgbClr val="E2DCCF"/>
+                      </a:solidFill>
+                      <a:prstDash val="solid"/>
+                      <a:round/>
+                      <a:headEnd type="none" w="med" len="med"/>
+                      <a:tailEnd type="none" w="med" len="med"/>
+                    </a:lnR>
+                    <a:lnT w="6350" cap="flat" cmpd="sng" algn="ctr">
+                      <a:solidFill>
+                        <a:srgbClr val="E2DCCF"/>
+                      </a:solidFill>
+                      <a:prstDash val="solid"/>
+                      <a:round/>
+                      <a:headEnd type="none" w="med" len="med"/>
+                      <a:tailEnd type="none" w="med" len="med"/>
+                    </a:lnT>
+                    <a:lnB w="6350" cap="flat" cmpd="sng" algn="ctr">
+                      <a:solidFill>
+                        <a:srgbClr val="E2DCCF"/>
+                      </a:solidFill>
+                      <a:prstDash val="solid"/>
+                      <a:round/>
+                      <a:headEnd type="none" w="med" len="med"/>
+                      <a:tailEnd type="none" w="med" len="med"/>
+                    </a:lnB>
+                    <a:solidFill>
+                      <a:srgbClr val="FFFFFF"/>
+                    </a:solidFill>
+                  </a:tcPr>
+                </a:tc>
+                <a:tc>
+                  <a:txBody>
+                    <a:bodyPr/>
+                    <a:lstStyle/>
+                    <a:p>
+                      <a:pPr algn="l" indent="0" marL="0">
+                        <a:buNone/>
+                      </a:pPr>
+                      <a:r>
+                        <a:rPr lang="en-US" sz="1150" dirty="0">
+                          <a:solidFill>
+                            <a:srgbClr val="1B2B31"/>
+                          </a:solidFill>
+                        </a:rPr>
+                        <a:t>Precision of the mean; tight because of the ÷√n. ← what we use: a big donor spread still gives a well-pinned mean.</a:t>
+                      </a:r>
+                      <a:endParaRPr lang="en-US" sz="1150" dirty="0"/>
+                    </a:p>
+                  </a:txBody>
+                  <a:tcPr marL="76200" marR="76200" marT="38100" marB="38100" anchor="ctr">
+                    <a:lnL w="6350" cap="flat" cmpd="sng" algn="ctr">
+                      <a:solidFill>
+                        <a:srgbClr val="E2DCCF"/>
+                      </a:solidFill>
+                      <a:prstDash val="solid"/>
+                      <a:round/>
+                      <a:headEnd type="none" w="med" len="med"/>
+                      <a:tailEnd type="none" w="med" len="med"/>
+                    </a:lnL>
+                    <a:lnR w="6350" cap="flat" cmpd="sng" algn="ctr">
+                      <a:solidFill>
+                        <a:srgbClr val="E2DCCF"/>
+                      </a:solidFill>
+                      <a:prstDash val="solid"/>
+                      <a:round/>
+                      <a:headEnd type="none" w="med" len="med"/>
+                      <a:tailEnd type="none" w="med" len="med"/>
+                    </a:lnR>
+                    <a:lnT w="6350" cap="flat" cmpd="sng" algn="ctr">
+                      <a:solidFill>
+                        <a:srgbClr val="E2DCCF"/>
+                      </a:solidFill>
+                      <a:prstDash val="solid"/>
+                      <a:round/>
+                      <a:headEnd type="none" w="med" len="med"/>
+                      <a:tailEnd type="none" w="med" len="med"/>
+                    </a:lnT>
+                    <a:lnB w="6350" cap="flat" cmpd="sng" algn="ctr">
+                      <a:solidFill>
+                        <a:srgbClr val="E2DCCF"/>
+                      </a:solidFill>
+                      <a:prstDash val="solid"/>
+                      <a:round/>
+                      <a:headEnd type="none" w="med" len="med"/>
+                      <a:tailEnd type="none" w="med" len="med"/>
+                    </a:lnB>
+                    <a:solidFill>
+                      <a:srgbClr val="FFFFFF"/>
+                    </a:solidFill>
+                  </a:tcPr>
+                </a:tc>
+              </a:tr>
+              <a:tr h="274320">
+                <a:tc>
+                  <a:txBody>
+                    <a:bodyPr/>
+                    <a:lstStyle/>
+                    <a:p>
+                      <a:pPr algn="l" indent="0" marL="0">
+                        <a:buNone/>
+                      </a:pPr>
+                      <a:r>
+                        <a:rPr lang="en-US" sz="1150" b="1" dirty="0">
+                          <a:solidFill>
+                            <a:srgbClr val="1B6E78"/>
+                          </a:solidFill>
+                        </a:rPr>
+                        <a:t>95% CI = SEM × t</a:t>
+                      </a:r>
+                      <a:endParaRPr lang="en-US" sz="1150" dirty="0"/>
+                    </a:p>
+                  </a:txBody>
+                  <a:tcPr marL="76200" marR="76200" marT="38100" marB="38100" anchor="ctr">
+                    <a:lnL w="6350" cap="flat" cmpd="sng" algn="ctr">
+                      <a:solidFill>
+                        <a:srgbClr val="E2DCCF"/>
+                      </a:solidFill>
+                      <a:prstDash val="solid"/>
+                      <a:round/>
+                      <a:headEnd type="none" w="med" len="med"/>
+                      <a:tailEnd type="none" w="med" len="med"/>
+                    </a:lnL>
+                    <a:lnR w="6350" cap="flat" cmpd="sng" algn="ctr">
+                      <a:solidFill>
+                        <a:srgbClr val="E2DCCF"/>
+                      </a:solidFill>
+                      <a:prstDash val="solid"/>
+                      <a:round/>
+                      <a:headEnd type="none" w="med" len="med"/>
+                      <a:tailEnd type="none" w="med" len="med"/>
+                    </a:lnR>
+                    <a:lnT w="6350" cap="flat" cmpd="sng" algn="ctr">
+                      <a:solidFill>
+                        <a:srgbClr val="E2DCCF"/>
+                      </a:solidFill>
+                      <a:prstDash val="solid"/>
+                      <a:round/>
+                      <a:headEnd type="none" w="med" len="med"/>
+                      <a:tailEnd type="none" w="med" len="med"/>
+                    </a:lnT>
+                    <a:lnB w="6350" cap="flat" cmpd="sng" algn="ctr">
+                      <a:solidFill>
+                        <a:srgbClr val="E2DCCF"/>
+                      </a:solidFill>
+                      <a:prstDash val="solid"/>
+                      <a:round/>
+                      <a:headEnd type="none" w="med" len="med"/>
+                      <a:tailEnd type="none" w="med" len="med"/>
+                    </a:lnB>
+                    <a:solidFill>
+                      <a:srgbClr val="FFFFFF"/>
+                    </a:solidFill>
+                  </a:tcPr>
+                </a:tc>
+                <a:tc>
+                  <a:txBody>
+                    <a:bodyPr/>
+                    <a:lstStyle/>
+                    <a:p>
+                      <a:pPr algn="l" indent="0" marL="0">
+                        <a:buNone/>
+                      </a:pPr>
+                      <a:r>
+                        <a:rPr lang="en-US" sz="1150" dirty="0">
+                          <a:solidFill>
+                            <a:srgbClr val="1B2B31"/>
+                          </a:solidFill>
+                        </a:rPr>
+                        <a:t>Also precision, but t ≈ 3.2 at n = 4 blows it up → reads “uncertain” and fights the “confident” message.</a:t>
+                      </a:r>
+                      <a:endParaRPr lang="en-US" sz="1150" dirty="0"/>
+                    </a:p>
+                  </a:txBody>
+                  <a:tcPr marL="76200" marR="76200" marT="38100" marB="38100" anchor="ctr">
+                    <a:lnL w="6350" cap="flat" cmpd="sng" algn="ctr">
+                      <a:solidFill>
+                        <a:srgbClr val="E2DCCF"/>
+                      </a:solidFill>
+                      <a:prstDash val="solid"/>
+                      <a:round/>
+                      <a:headEnd type="none" w="med" len="med"/>
+                      <a:tailEnd type="none" w="med" len="med"/>
+                    </a:lnL>
+                    <a:lnR w="6350" cap="flat" cmpd="sng" algn="ctr">
+                      <a:solidFill>
+                        <a:srgbClr val="E2DCCF"/>
+                      </a:solidFill>
+                      <a:prstDash val="solid"/>
+                      <a:round/>
+                      <a:headEnd type="none" w="med" len="med"/>
+                      <a:tailEnd type="none" w="med" len="med"/>
+                    </a:lnR>
+                    <a:lnT w="6350" cap="flat" cmpd="sng" algn="ctr">
+                      <a:solidFill>
+                        <a:srgbClr val="E2DCCF"/>
+                      </a:solidFill>
+                      <a:prstDash val="solid"/>
+                      <a:round/>
+                      <a:headEnd type="none" w="med" len="med"/>
+                      <a:tailEnd type="none" w="med" len="med"/>
+                    </a:lnT>
+                    <a:lnB w="6350" cap="flat" cmpd="sng" algn="ctr">
+                      <a:solidFill>
+                        <a:srgbClr val="E2DCCF"/>
+                      </a:solidFill>
+                      <a:prstDash val="solid"/>
+                      <a:round/>
+                      <a:headEnd type="none" w="med" len="med"/>
+                      <a:tailEnd type="none" w="med" len="med"/>
+                    </a:lnB>
+                    <a:solidFill>
+                      <a:srgbClr val="FFFFFF"/>
+                    </a:solidFill>
+                  </a:tcPr>
+                </a:tc>
+              </a:tr>
+              <a:tr h="274320">
+                <a:tc>
+                  <a:txBody>
+                    <a:bodyPr/>
+                    <a:lstStyle/>
+                    <a:p>
+                      <a:pPr algn="l" indent="0" marL="0">
+                        <a:buNone/>
+                      </a:pPr>
+                      <a:r>
+                        <a:rPr lang="en-US" sz="1150" b="1" dirty="0">
+                          <a:solidFill>
+                            <a:srgbClr val="1B6E78"/>
+                          </a:solidFill>
+                        </a:rPr>
+                        <a:t>Mean, not median</a:t>
+                      </a:r>
+                      <a:endParaRPr lang="en-US" sz="1150" dirty="0"/>
+                    </a:p>
+                  </a:txBody>
+                  <a:tcPr marL="76200" marR="76200" marT="38100" marB="38100" anchor="ctr">
+                    <a:lnL w="6350" cap="flat" cmpd="sng" algn="ctr">
+                      <a:solidFill>
+                        <a:srgbClr val="E2DCCF"/>
+                      </a:solidFill>
+                      <a:prstDash val="solid"/>
+                      <a:round/>
+                      <a:headEnd type="none" w="med" len="med"/>
+                      <a:tailEnd type="none" w="med" len="med"/>
+                    </a:lnL>
+                    <a:lnR w="6350" cap="flat" cmpd="sng" algn="ctr">
+                      <a:solidFill>
+                        <a:srgbClr val="E2DCCF"/>
+                      </a:solidFill>
+                      <a:prstDash val="solid"/>
+                      <a:round/>
+                      <a:headEnd type="none" w="med" len="med"/>
+                      <a:tailEnd type="none" w="med" len="med"/>
+                    </a:lnR>
+                    <a:lnT w="6350" cap="flat" cmpd="sng" algn="ctr">
+                      <a:solidFill>
+                        <a:srgbClr val="E2DCCF"/>
+                      </a:solidFill>
+                      <a:prstDash val="solid"/>
+                      <a:round/>
+                      <a:headEnd type="none" w="med" len="med"/>
+                      <a:tailEnd type="none" w="med" len="med"/>
+                    </a:lnT>
+                    <a:lnB w="6350" cap="flat" cmpd="sng" algn="ctr">
+                      <a:solidFill>
+                        <a:srgbClr val="E2DCCF"/>
+                      </a:solidFill>
+                      <a:prstDash val="solid"/>
+                      <a:round/>
+                      <a:headEnd type="none" w="med" len="med"/>
+                      <a:tailEnd type="none" w="med" len="med"/>
+                    </a:lnB>
+                    <a:solidFill>
+                      <a:srgbClr val="FFFFFF"/>
+                    </a:solidFill>
+                  </a:tcPr>
+                </a:tc>
+                <a:tc>
+                  <a:txBody>
+                    <a:bodyPr/>
+                    <a:lstStyle/>
+                    <a:p>
+                      <a:pPr algn="l" indent="0" marL="0">
+                        <a:buNone/>
+                      </a:pPr>
+                      <a:r>
+                        <a:rPr lang="en-US" sz="1150" dirty="0">
+                          <a:solidFill>
+                            <a:srgbClr val="1B2B31"/>
+                          </a:solidFill>
+                        </a:rPr>
+                        <a:t>The inference (TOST, SE ≈ 4 pp) is mean-based; a median center would describe a different quantity than the test. Median + IQR is the box again.</a:t>
+                      </a:r>
+                      <a:endParaRPr lang="en-US" sz="1150" dirty="0"/>
+                    </a:p>
+                  </a:txBody>
+                  <a:tcPr marL="76200" marR="76200" marT="38100" marB="38100" anchor="ctr">
+                    <a:lnL w="6350" cap="flat" cmpd="sng" algn="ctr">
+                      <a:solidFill>
+                        <a:srgbClr val="E2DCCF"/>
+                      </a:solidFill>
+                      <a:prstDash val="solid"/>
+                      <a:round/>
+                      <a:headEnd type="none" w="med" len="med"/>
+                      <a:tailEnd type="none" w="med" len="med"/>
+                    </a:lnL>
+                    <a:lnR w="6350" cap="flat" cmpd="sng" algn="ctr">
+                      <a:solidFill>
+                        <a:srgbClr val="E2DCCF"/>
+                      </a:solidFill>
+                      <a:prstDash val="solid"/>
+                      <a:round/>
+                      <a:headEnd type="none" w="med" len="med"/>
+                      <a:tailEnd type="none" w="med" len="med"/>
+                    </a:lnR>
+                    <a:lnT w="6350" cap="flat" cmpd="sng" algn="ctr">
+                      <a:solidFill>
+                        <a:srgbClr val="E2DCCF"/>
+                      </a:solidFill>
+                      <a:prstDash val="solid"/>
+                      <a:round/>
+                      <a:headEnd type="none" w="med" len="med"/>
+                      <a:tailEnd type="none" w="med" len="med"/>
+                    </a:lnT>
+                    <a:lnB w="6350" cap="flat" cmpd="sng" algn="ctr">
+                      <a:solidFill>
+                        <a:srgbClr val="E2DCCF"/>
+                      </a:solidFill>
+                      <a:prstDash val="solid"/>
+                      <a:round/>
+                      <a:headEnd type="none" w="med" len="med"/>
+                      <a:tailEnd type="none" w="med" len="med"/>
+                    </a:lnB>
+                    <a:solidFill>
+                      <a:srgbClr val="FFFFFF"/>
+                    </a:solidFill>
+                  </a:tcPr>
+                </a:tc>
+              </a:tr>
+              <a:tr h="274320">
+                <a:tc>
+                  <a:txBody>
+                    <a:bodyPr/>
+                    <a:lstStyle/>
+                    <a:p>
+                      <a:pPr algn="l" indent="0" marL="0">
+                        <a:buNone/>
+                      </a:pPr>
+                      <a:r>
+                        <a:rPr lang="en-US" sz="1150" b="1" dirty="0">
+                          <a:solidFill>
+                            <a:srgbClr val="1B6E78"/>
+                          </a:solidFill>
+                        </a:rPr>
+                        <a:t>Honest, not stat-picking</a:t>
+                      </a:r>
+                      <a:endParaRPr lang="en-US" sz="1150" dirty="0"/>
+                    </a:p>
+                  </a:txBody>
+                  <a:tcPr marL="76200" marR="76200" marT="38100" marB="38100" anchor="ctr">
+                    <a:lnL w="6350" cap="flat" cmpd="sng" algn="ctr">
+                      <a:solidFill>
+                        <a:srgbClr val="E2DCCF"/>
+                      </a:solidFill>
+                      <a:prstDash val="solid"/>
+                      <a:round/>
+                      <a:headEnd type="none" w="med" len="med"/>
+                      <a:tailEnd type="none" w="med" len="med"/>
+                    </a:lnL>
+                    <a:lnR w="6350" cap="flat" cmpd="sng" algn="ctr">
+                      <a:solidFill>
+                        <a:srgbClr val="E2DCCF"/>
+                      </a:solidFill>
+                      <a:prstDash val="solid"/>
+                      <a:round/>
+                      <a:headEnd type="none" w="med" len="med"/>
+                      <a:tailEnd type="none" w="med" len="med"/>
+                    </a:lnR>
+                    <a:lnT w="6350" cap="flat" cmpd="sng" algn="ctr">
+                      <a:solidFill>
+                        <a:srgbClr val="E2DCCF"/>
+                      </a:solidFill>
+                      <a:prstDash val="solid"/>
+                      <a:round/>
+                      <a:headEnd type="none" w="med" len="med"/>
+                      <a:tailEnd type="none" w="med" len="med"/>
+                    </a:lnT>
+                    <a:lnB w="6350" cap="flat" cmpd="sng" algn="ctr">
+                      <a:solidFill>
+                        <a:srgbClr val="E2DCCF"/>
+                      </a:solidFill>
+                      <a:prstDash val="solid"/>
+                      <a:round/>
+                      <a:headEnd type="none" w="med" len="med"/>
+                      <a:tailEnd type="none" w="med" len="med"/>
+                    </a:lnB>
+                    <a:solidFill>
+                      <a:srgbClr val="FFFFFF"/>
+                    </a:solidFill>
+                  </a:tcPr>
+                </a:tc>
+                <a:tc>
+                  <a:txBody>
+                    <a:bodyPr/>
+                    <a:lstStyle/>
+                    <a:p>
+                      <a:pPr algn="l" indent="0" marL="0">
+                        <a:buNone/>
+                      </a:pPr>
+                      <a:r>
+                        <a:rPr lang="en-US" sz="1150" dirty="0">
+                          <a:solidFill>
+                            <a:srgbClr val="1B2B31"/>
+                          </a:solidFill>
+                        </a:rPr>
+                        <a:t>Raw dots shown; equivalence stated both ways; and a real change WAS found (detox dimming, ρ = −0.48) → a genuine null, not a power failure. Soft spot: F4 n = 4.</a:t>
+                      </a:r>
+                      <a:endParaRPr lang="en-US" sz="1150" dirty="0"/>
+                    </a:p>
+                  </a:txBody>
+                  <a:tcPr marL="76200" marR="76200" marT="38100" marB="38100" anchor="ctr">
+                    <a:lnL w="6350" cap="flat" cmpd="sng" algn="ctr">
+                      <a:solidFill>
+                        <a:srgbClr val="E2DCCF"/>
+                      </a:solidFill>
+                      <a:prstDash val="solid"/>
+                      <a:round/>
+                      <a:headEnd type="none" w="med" len="med"/>
+                      <a:tailEnd type="none" w="med" len="med"/>
+                    </a:lnL>
+                    <a:lnR w="6350" cap="flat" cmpd="sng" algn="ctr">
+                      <a:solidFill>
+                        <a:srgbClr val="E2DCCF"/>
+                      </a:solidFill>
+                      <a:prstDash val="solid"/>
+                      <a:round/>
+                      <a:headEnd type="none" w="med" len="med"/>
+                      <a:tailEnd type="none" w="med" len="med"/>
+                    </a:lnR>
+                    <a:lnT w="6350" cap="flat" cmpd="sng" algn="ctr">
+                      <a:solidFill>
+                        <a:srgbClr val="E2DCCF"/>
+                      </a:solidFill>
+                      <a:prstDash val="solid"/>
+                      <a:round/>
+                      <a:headEnd type="none" w="med" len="med"/>
+                      <a:tailEnd type="none" w="med" len="med"/>
+                    </a:lnT>
+                    <a:lnB w="6350" cap="flat" cmpd="sng" algn="ctr">
+                      <a:solidFill>
+                        <a:srgbClr val="E2DCCF"/>
+                      </a:solidFill>
+                      <a:prstDash val="solid"/>
+                      <a:round/>
+                      <a:headEnd type="none" w="med" len="med"/>
+                      <a:tailEnd type="none" w="med" len="med"/>
+                    </a:lnB>
+                    <a:solidFill>
+                      <a:srgbClr val="FFFFFF"/>
+                    </a:solidFill>
+                  </a:tcPr>
+                </a:tc>
+              </a:tr>
+              <a:tr h="274320">
+                <a:tc>
+                  <a:txBody>
+                    <a:bodyPr/>
+                    <a:lstStyle/>
+                    <a:p>
+                      <a:pPr algn="l" indent="0" marL="0">
+                        <a:buNone/>
+                      </a:pPr>
+                      <a:r>
+                        <a:rPr lang="en-US" sz="1150" b="1" dirty="0">
+                          <a:solidFill>
+                            <a:srgbClr val="1B6E78"/>
+                          </a:solidFill>
+                        </a:rPr>
+                        <a:t>✗ Don't claim</a:t>
+                      </a:r>
+                      <a:endParaRPr lang="en-US" sz="1150" dirty="0"/>
+                    </a:p>
+                  </a:txBody>
+                  <a:tcPr marL="76200" marR="76200" marT="38100" marB="38100" anchor="ctr">
+                    <a:lnL w="6350" cap="flat" cmpd="sng" algn="ctr">
+                      <a:solidFill>
+                        <a:srgbClr val="E2DCCF"/>
+                      </a:solidFill>
+                      <a:prstDash val="solid"/>
+                      <a:round/>
+                      <a:headEnd type="none" w="med" len="med"/>
+                      <a:tailEnd type="none" w="med" len="med"/>
+                    </a:lnL>
+                    <a:lnR w="6350" cap="flat" cmpd="sng" algn="ctr">
+                      <a:solidFill>
+                        <a:srgbClr val="E2DCCF"/>
+                      </a:solidFill>
+                      <a:prstDash val="solid"/>
+                      <a:round/>
+                      <a:headEnd type="none" w="med" len="med"/>
+                      <a:tailEnd type="none" w="med" len="med"/>
+                    </a:lnR>
+                    <a:lnT w="6350" cap="flat" cmpd="sng" algn="ctr">
+                      <a:solidFill>
+                        <a:srgbClr val="E2DCCF"/>
+                      </a:solidFill>
+                      <a:prstDash val="solid"/>
+                      <a:round/>
+                      <a:headEnd type="none" w="med" len="med"/>
+                      <a:tailEnd type="none" w="med" len="med"/>
+                    </a:lnT>
+                    <a:lnB w="6350" cap="flat" cmpd="sng" algn="ctr">
+                      <a:solidFill>
+                        <a:srgbClr val="E2DCCF"/>
+                      </a:solidFill>
+                      <a:prstDash val="solid"/>
+                      <a:round/>
+                      <a:headEnd type="none" w="med" len="med"/>
+                      <a:tailEnd type="none" w="med" len="med"/>
+                    </a:lnB>
+                    <a:solidFill>
+                      <a:srgbClr val="FFFFFF"/>
+                    </a:solidFill>
+                  </a:tcPr>
+                </a:tc>
+                <a:tc>
+                  <a:txBody>
+                    <a:bodyPr/>
+                    <a:lstStyle/>
+                    <a:p>
+                      <a:pPr algn="l" indent="0" marL="0">
+                        <a:buNone/>
+                      </a:pPr>
+                      <a:r>
+                        <a:rPr lang="en-US" sz="1150" dirty="0">
+                          <a:solidFill>
+                            <a:srgbClr val="1B2B31"/>
+                          </a:solidFill>
+                        </a:rPr>
+                        <a:t>“zonation is intact / preserved” — can't prove a negative; underpowered (F4 n = 4).</a:t>
+                      </a:r>
+                      <a:endParaRPr lang="en-US" sz="1150" dirty="0"/>
+                    </a:p>
+                  </a:txBody>
+                  <a:tcPr marL="76200" marR="76200" marT="38100" marB="38100" anchor="ctr">
+                    <a:lnL w="6350" cap="flat" cmpd="sng" algn="ctr">
+                      <a:solidFill>
+                        <a:srgbClr val="E2DCCF"/>
+                      </a:solidFill>
+                      <a:prstDash val="solid"/>
+                      <a:round/>
+                      <a:headEnd type="none" w="med" len="med"/>
+                      <a:tailEnd type="none" w="med" len="med"/>
+                    </a:lnL>
+                    <a:lnR w="6350" cap="flat" cmpd="sng" algn="ctr">
+                      <a:solidFill>
+                        <a:srgbClr val="E2DCCF"/>
+                      </a:solidFill>
+                      <a:prstDash val="solid"/>
+                      <a:round/>
+                      <a:headEnd type="none" w="med" len="med"/>
+                      <a:tailEnd type="none" w="med" len="med"/>
+                    </a:lnR>
+                    <a:lnT w="6350" cap="flat" cmpd="sng" algn="ctr">
+                      <a:solidFill>
+                        <a:srgbClr val="E2DCCF"/>
+                      </a:solidFill>
+                      <a:prstDash val="solid"/>
+                      <a:round/>
+                      <a:headEnd type="none" w="med" len="med"/>
+                      <a:tailEnd type="none" w="med" len="med"/>
+                    </a:lnT>
+                    <a:lnB w="6350" cap="flat" cmpd="sng" algn="ctr">
+                      <a:solidFill>
+                        <a:srgbClr val="E2DCCF"/>
+                      </a:solidFill>
+                      <a:prstDash val="solid"/>
+                      <a:round/>
+                      <a:headEnd type="none" w="med" len="med"/>
+                      <a:tailEnd type="none" w="med" len="med"/>
+                    </a:lnB>
+                    <a:solidFill>
+                      <a:srgbClr val="FFFFFF"/>
+                    </a:solidFill>
+                  </a:tcPr>
+                </a:tc>
+              </a:tr>
+              <a:tr h="274320">
+                <a:tc>
+                  <a:txBody>
+                    <a:bodyPr/>
+                    <a:lstStyle/>
+                    <a:p>
+                      <a:pPr algn="l" indent="0" marL="0">
+                        <a:buNone/>
+                      </a:pPr>
+                      <a:r>
+                        <a:rPr lang="en-US" sz="1150" b="1" dirty="0">
+                          <a:solidFill>
+                            <a:srgbClr val="1B6E78"/>
+                          </a:solidFill>
+                        </a:rPr>
+                        <a:t>✓ Do claim</a:t>
+                      </a:r>
+                      <a:endParaRPr lang="en-US" sz="1150" dirty="0"/>
+                    </a:p>
+                  </a:txBody>
+                  <a:tcPr marL="76200" marR="76200" marT="38100" marB="38100" anchor="ctr">
+                    <a:lnL w="6350" cap="flat" cmpd="sng" algn="ctr">
+                      <a:solidFill>
+                        <a:srgbClr val="E2DCCF"/>
+                      </a:solidFill>
+                      <a:prstDash val="solid"/>
+                      <a:round/>
+                      <a:headEnd type="none" w="med" len="med"/>
+                      <a:tailEnd type="none" w="med" len="med"/>
+                    </a:lnL>
+                    <a:lnR w="6350" cap="flat" cmpd="sng" algn="ctr">
+                      <a:solidFill>
+                        <a:srgbClr val="E2DCCF"/>
+                      </a:solidFill>
+                      <a:prstDash val="solid"/>
+                      <a:round/>
+                      <a:headEnd type="none" w="med" len="med"/>
+                      <a:tailEnd type="none" w="med" len="med"/>
+                    </a:lnR>
+                    <a:lnT w="6350" cap="flat" cmpd="sng" algn="ctr">
+                      <a:solidFill>
+                        <a:srgbClr val="E2DCCF"/>
+                      </a:solidFill>
+                      <a:prstDash val="solid"/>
+                      <a:round/>
+                      <a:headEnd type="none" w="med" len="med"/>
+                      <a:tailEnd type="none" w="med" len="med"/>
+                    </a:lnT>
+                    <a:lnB w="6350" cap="flat" cmpd="sng" algn="ctr">
+                      <a:solidFill>
+                        <a:srgbClr val="E2DCCF"/>
+                      </a:solidFill>
+                      <a:prstDash val="solid"/>
+                      <a:round/>
+                      <a:headEnd type="none" w="med" len="med"/>
+                      <a:tailEnd type="none" w="med" len="med"/>
+                    </a:lnB>
+                    <a:solidFill>
+                      <a:srgbClr val="FFFFFF"/>
+                    </a:solidFill>
+                  </a:tcPr>
+                </a:tc>
+                <a:tc>
+                  <a:txBody>
+                    <a:bodyPr/>
+                    <a:lstStyle/>
+                    <a:p>
+                      <a:pPr algn="l" indent="0" marL="0">
+                        <a:buNone/>
+                      </a:pPr>
+                      <a:r>
+                        <a:rPr lang="en-US" sz="1150" dirty="0">
+                          <a:solidFill>
+                            <a:srgbClr val="1B2B31"/>
+                          </a:solidFill>
+                        </a:rPr>
+                        <a:t>No detectable de-zonation signal; a large shift (&gt; ±19 pp) is excluded (TOST); a subtle ≤ 10 pp drift is not (F4 n = 4).</a:t>
                       </a:r>
                       <a:endParaRPr lang="en-US" sz="1150" dirty="0"/>
                     </a:p>

</xml_diff>